<commit_message>
updated slides and instructions
</commit_message>
<xml_diff>
--- a/2026_SMDM/admin/Instructions.pptx
+++ b/2026_SMDM/admin/Instructions.pptx
@@ -259,7 +259,7 @@
           <a:p>
             <a:fld id="{1F06E6B4-D2D1-8340-BB5C-DBF76C96EA3F}" type="datetimeFigureOut">
               <a:rPr lang="en-US" smtClean="0"/>
-              <a:t>6/14/25</a:t>
+              <a:t>6/27/26</a:t>
             </a:fld>
             <a:endParaRPr lang="en-US"/>
           </a:p>
@@ -457,7 +457,7 @@
           <a:p>
             <a:fld id="{1F06E6B4-D2D1-8340-BB5C-DBF76C96EA3F}" type="datetimeFigureOut">
               <a:rPr lang="en-US" smtClean="0"/>
-              <a:t>6/14/25</a:t>
+              <a:t>6/27/26</a:t>
             </a:fld>
             <a:endParaRPr lang="en-US"/>
           </a:p>
@@ -665,7 +665,7 @@
           <a:p>
             <a:fld id="{1F06E6B4-D2D1-8340-BB5C-DBF76C96EA3F}" type="datetimeFigureOut">
               <a:rPr lang="en-US" smtClean="0"/>
-              <a:t>6/14/25</a:t>
+              <a:t>6/27/26</a:t>
             </a:fld>
             <a:endParaRPr lang="en-US"/>
           </a:p>
@@ -863,7 +863,7 @@
           <a:p>
             <a:fld id="{1F06E6B4-D2D1-8340-BB5C-DBF76C96EA3F}" type="datetimeFigureOut">
               <a:rPr lang="en-US" smtClean="0"/>
-              <a:t>6/14/25</a:t>
+              <a:t>6/27/26</a:t>
             </a:fld>
             <a:endParaRPr lang="en-US"/>
           </a:p>
@@ -1138,7 +1138,7 @@
           <a:p>
             <a:fld id="{1F06E6B4-D2D1-8340-BB5C-DBF76C96EA3F}" type="datetimeFigureOut">
               <a:rPr lang="en-US" smtClean="0"/>
-              <a:t>6/14/25</a:t>
+              <a:t>6/27/26</a:t>
             </a:fld>
             <a:endParaRPr lang="en-US"/>
           </a:p>
@@ -1403,7 +1403,7 @@
           <a:p>
             <a:fld id="{1F06E6B4-D2D1-8340-BB5C-DBF76C96EA3F}" type="datetimeFigureOut">
               <a:rPr lang="en-US" smtClean="0"/>
-              <a:t>6/14/25</a:t>
+              <a:t>6/27/26</a:t>
             </a:fld>
             <a:endParaRPr lang="en-US"/>
           </a:p>
@@ -1815,7 +1815,7 @@
           <a:p>
             <a:fld id="{1F06E6B4-D2D1-8340-BB5C-DBF76C96EA3F}" type="datetimeFigureOut">
               <a:rPr lang="en-US" smtClean="0"/>
-              <a:t>6/14/25</a:t>
+              <a:t>6/27/26</a:t>
             </a:fld>
             <a:endParaRPr lang="en-US"/>
           </a:p>
@@ -1956,7 +1956,7 @@
           <a:p>
             <a:fld id="{1F06E6B4-D2D1-8340-BB5C-DBF76C96EA3F}" type="datetimeFigureOut">
               <a:rPr lang="en-US" smtClean="0"/>
-              <a:t>6/14/25</a:t>
+              <a:t>6/27/26</a:t>
             </a:fld>
             <a:endParaRPr lang="en-US"/>
           </a:p>
@@ -2069,7 +2069,7 @@
           <a:p>
             <a:fld id="{1F06E6B4-D2D1-8340-BB5C-DBF76C96EA3F}" type="datetimeFigureOut">
               <a:rPr lang="en-US" smtClean="0"/>
-              <a:t>6/14/25</a:t>
+              <a:t>6/27/26</a:t>
             </a:fld>
             <a:endParaRPr lang="en-US"/>
           </a:p>
@@ -2380,7 +2380,7 @@
           <a:p>
             <a:fld id="{1F06E6B4-D2D1-8340-BB5C-DBF76C96EA3F}" type="datetimeFigureOut">
               <a:rPr lang="en-US" smtClean="0"/>
-              <a:t>6/14/25</a:t>
+              <a:t>6/27/26</a:t>
             </a:fld>
             <a:endParaRPr lang="en-US"/>
           </a:p>
@@ -2668,7 +2668,7 @@
           <a:p>
             <a:fld id="{1F06E6B4-D2D1-8340-BB5C-DBF76C96EA3F}" type="datetimeFigureOut">
               <a:rPr lang="en-US" smtClean="0"/>
-              <a:t>6/14/25</a:t>
+              <a:t>6/27/26</a:t>
             </a:fld>
             <a:endParaRPr lang="en-US"/>
           </a:p>
@@ -2909,7 +2909,7 @@
           <a:p>
             <a:fld id="{1F06E6B4-D2D1-8340-BB5C-DBF76C96EA3F}" type="datetimeFigureOut">
               <a:rPr lang="en-US" smtClean="0"/>
-              <a:t>6/14/25</a:t>
+              <a:t>6/27/26</a:t>
             </a:fld>
             <a:endParaRPr lang="en-US"/>
           </a:p>
@@ -3604,7 +3604,7 @@
           <p:spPr>
             <a:xfrm>
               <a:off x="1718904" y="172720"/>
-              <a:ext cx="1981200" cy="923330"/>
+              <a:ext cx="1981200" cy="1200329"/>
             </a:xfrm>
             <a:prstGeom prst="rect">
               <a:avLst/>
@@ -3628,7 +3628,7 @@
                     <a:srgbClr val="FF0000"/>
                   </a:solidFill>
                 </a:rPr>
-                <a:t>Click here to download a zip file  with the materials</a:t>
+                <a:t>Click here to download a zip file  with the materials from your course</a:t>
               </a:r>
             </a:p>
           </p:txBody>
@@ -3651,8 +3651,8 @@
           </p:nvCxnSpPr>
           <p:spPr>
             <a:xfrm flipH="1">
-              <a:off x="2294792" y="1096050"/>
-              <a:ext cx="414712" cy="556904"/>
+              <a:off x="2294792" y="1373049"/>
+              <a:ext cx="414712" cy="279905"/>
             </a:xfrm>
             <a:prstGeom prst="line">
               <a:avLst/>

</xml_diff>